<commit_message>
Justification du choix 5 jours (notebook et slide), coherence meteo
</commit_message>
<xml_diff>
--- a/1-Construire et gérer une infrastructure de données/Projet-Planifiez votre voyage avec Kayak/docs/Kayak_Story_slides.pptx
+++ b/1-Construire et gérer une infrastructure de données/Projet-Planifiez votre voyage avec Kayak/docs/Kayak_Story_slides.pptx
@@ -2395,7 +2395,7 @@
                 <a:ea typeface="Calibri" pitchFamily="34" charset="-122"/>
                 <a:cs typeface="Calibri" pitchFamily="34" charset="-120"/>
               </a:rPr>
-              <a:t>104 hôtels</a:t>
+              <a:t>105 hôtels</a:t>
             </a:r>
             <a:endParaRPr lang="en-US" sz="1100" dirty="0"/>
           </a:p>
@@ -2854,7 +2854,7 @@
           <p:nvPr/>
         </p:nvPicPr>
         <p:blipFill>
-          <a:blip r:embed="rId3"/>
+          <a:blip r:embed="rId5"/>
           <a:stretch>
             <a:fillRect/>
           </a:stretch>
@@ -3250,7 +3250,7 @@
                 <a:ea typeface="Calibri" pitchFamily="34" charset="-122"/>
                 <a:cs typeface="Calibri" pitchFamily="34" charset="-120"/>
               </a:rPr>
-              <a:t>104</a:t>
+              <a:t>105</a:t>
             </a:r>
             <a:endParaRPr lang="en-US" sz="3000" dirty="0"/>
           </a:p>
@@ -4532,7 +4532,7 @@
                 <a:ea typeface="Calibri" pitchFamily="34" charset="-122"/>
                 <a:cs typeface="Calibri" pitchFamily="34" charset="-120"/>
               </a:rPr>
-              <a:t>Météo 7j · 3 Ko</a:t>
+              <a:t>Météo 5j · 3 Ko</a:t>
             </a:r>
             <a:endParaRPr lang="en-US" sz="800" dirty="0"/>
           </a:p>
@@ -4894,7 +4894,7 @@
                 <a:ea typeface="Calibri" pitchFamily="34" charset="-122"/>
                 <a:cs typeface="Calibri" pitchFamily="34" charset="-120"/>
               </a:rPr>
-              <a:t>104 hôtels nettoyés · 52 Ko</a:t>
+              <a:t>105 hôtels nettoyés · 52 Ko</a:t>
             </a:r>
             <a:endParaRPr lang="en-US" sz="800" dirty="0"/>
           </a:p>
@@ -6614,7 +6614,7 @@
                 <a:ea typeface="Calibri" pitchFamily="34" charset="-122"/>
                 <a:cs typeface="Calibri" pitchFamily="34" charset="-120"/>
               </a:rPr>
-              <a:t>104</a:t>
+              <a:t>105</a:t>
             </a:r>
             <a:endParaRPr lang="en-US" sz="2800" dirty="0"/>
           </a:p>

</xml_diff>

<commit_message>
Infrastructure locale MinIO + PostgreSQL : notebook, README, presentation et captures a jour
</commit_message>
<xml_diff>
--- a/1-Construire et gérer une infrastructure de données/Projet-Planifiez votre voyage avec Kayak/docs/Kayak_Story_slides.pptx
+++ b/1-Construire et gérer une infrastructure de données/Projet-Planifiez votre voyage avec Kayak/docs/Kayak_Story_slides.pptx
@@ -1770,7 +1770,7 @@
                 <a:ea typeface="Calibri" pitchFamily="34" charset="-122"/>
                 <a:cs typeface="Calibri" pitchFamily="34" charset="-120"/>
               </a:rPr>
-              <a:t>AWS S3</a:t>
+              <a:t>S3 / MinIO</a:t>
             </a:r>
             <a:endParaRPr lang="en-US" sz="850" dirty="0"/>
           </a:p>
@@ -1843,7 +1843,7 @@
                 <a:ea typeface="Calibri" pitchFamily="34" charset="-122"/>
                 <a:cs typeface="Calibri" pitchFamily="34" charset="-120"/>
               </a:rPr>
-              <a:t>AWS RDS</a:t>
+              <a:t>PostgreSQL</a:t>
             </a:r>
             <a:endParaRPr lang="en-US" sz="850" dirty="0"/>
           </a:p>
@@ -2544,7 +2544,7 @@
                 <a:ea typeface="Calibri" pitchFamily="34" charset="-122"/>
                 <a:cs typeface="Calibri" pitchFamily="34" charset="-120"/>
               </a:rPr>
-              <a:t>dont 4 sur AWS S3</a:t>
+              <a:t>dont 4 sur S3 (MinIO)</a:t>
             </a:r>
             <a:endParaRPr lang="en-US" sz="1000" dirty="0"/>
           </a:p>
@@ -2654,7 +2654,7 @@
                 <a:ea typeface="Calibri" pitchFamily="34" charset="-122"/>
                 <a:cs typeface="Calibri" pitchFamily="34" charset="-120"/>
               </a:rPr>
-              <a:t>cities + hotels (RDS)</a:t>
+              <a:t>cities + hotels (PostgreSQL)</a:t>
             </a:r>
             <a:endParaRPr lang="en-US" sz="1000" dirty="0"/>
           </a:p>
@@ -2835,7 +2835,7 @@
                 <a:ea typeface="Calibri" pitchFamily="34" charset="-122"/>
                 <a:cs typeface="Calibri" pitchFamily="34" charset="-120"/>
               </a:rPr>
-              <a:t>Pipeline : Nominatim · OpenWeatherMap · Selenium → Pandas ETL → AWS S3 → AWS RDS → Plotly Express</a:t>
+              <a:t>Pipeline : Nominatim · OpenWeatherMap · Selenium → Pandas ETL → S3 (MinIO) → PostgreSQL → Plotly Express</a:t>
             </a:r>
             <a:endParaRPr lang="en-US" sz="850" dirty="0">
               <a:solidFill>
@@ -3440,7 +3440,7 @@
                 <a:ea typeface="Calibri" pitchFamily="34" charset="-122"/>
                 <a:cs typeface="Calibri" pitchFamily="34" charset="-120"/>
               </a:rPr>
-              <a:t>sur AWS S3</a:t>
+              <a:t>sur S3 (MinIO)</a:t>
             </a:r>
             <a:endParaRPr lang="en-US" sz="900" dirty="0"/>
           </a:p>
@@ -3574,7 +3574,7 @@
                 <a:ea typeface="Calibri" pitchFamily="34" charset="-122"/>
                 <a:cs typeface="Calibri" pitchFamily="34" charset="-120"/>
               </a:rPr>
-              <a:t>sur AWS RDS</a:t>
+              <a:t>sur PostgreSQL</a:t>
             </a:r>
             <a:endParaRPr lang="en-US" sz="900" dirty="0"/>
           </a:p>
@@ -4170,7 +4170,7 @@
                 <a:ea typeface="Calibri" pitchFamily="34" charset="-122"/>
                 <a:cs typeface="Calibri" pitchFamily="34" charset="-120"/>
               </a:rPr>
-              <a:t>AWS S3 : Data Lake</a:t>
+              <a:t>Data Lake : S3 / MinIO</a:t>
             </a:r>
             <a:endParaRPr lang="en-US" sz="1200" dirty="0"/>
           </a:p>
@@ -5366,7 +5366,7 @@
                 <a:ea typeface="Calibri" pitchFamily="34" charset="-122"/>
                 <a:cs typeface="Calibri" pitchFamily="34" charset="-120"/>
               </a:rPr>
-              <a:t>AWS RDS : Data Warehouse</a:t>
+              <a:t>Data Warehouse : PostgreSQL</a:t>
             </a:r>
             <a:endParaRPr lang="en-US" sz="1200" dirty="0"/>
           </a:p>
@@ -5914,7 +5914,7 @@
                 <a:ea typeface="Calibri" pitchFamily="34" charset="-122"/>
                 <a:cs typeface="Calibri" pitchFamily="34" charset="-120"/>
               </a:rPr>
-              <a:t>Cloud : AWS S3 (4 CSV uploadés · boto3) · AWS RDS PostgreSQL (2 tables · SQLAlchemy)  |  Score : critères normalisés 0-1, pondérés 40/40/20 (météo · hôtels · pluie)</a:t>
+              <a:t>Stockage : S3-compatible MinIO (4 CSV · boto3) · PostgreSQL (2 tables · SQLAlchemy), équivalents AWS S3/RDS  |  Score : critères normalisés 0-1, pondérés 40/40/20 (météo · hôtels · pluie)</a:t>
             </a:r>
             <a:endParaRPr lang="en-US" sz="850" dirty="0">
               <a:solidFill>
@@ -6278,7 +6278,7 @@
                 <a:ea typeface="Calibri" pitchFamily="34" charset="-122"/>
                 <a:cs typeface="Calibri" pitchFamily="34" charset="-120"/>
               </a:rPr>
-              <a:t>Architecture Data Lake S3 / Data Warehouse RDS séparée</a:t>
+              <a:t>Architecture Data Lake / Data Warehouse séparée (MinIO · PostgreSQL)</a:t>
             </a:r>
             <a:endParaRPr lang="en-US" sz="1000" dirty="0"/>
           </a:p>
@@ -6804,7 +6804,7 @@
                 <a:ea typeface="Calibri" pitchFamily="34" charset="-122"/>
                 <a:cs typeface="Calibri" pitchFamily="34" charset="-120"/>
               </a:rPr>
-              <a:t>AWS S3</a:t>
+              <a:t>S3 / MinIO</a:t>
             </a:r>
             <a:endParaRPr lang="en-US" sz="850" dirty="0"/>
           </a:p>
@@ -6938,7 +6938,7 @@
                 <a:ea typeface="Calibri" pitchFamily="34" charset="-122"/>
                 <a:cs typeface="Calibri" pitchFamily="34" charset="-120"/>
               </a:rPr>
-              <a:t>sur RDS</a:t>
+              <a:t>sur PostgreSQL</a:t>
             </a:r>
             <a:endParaRPr lang="en-US" sz="850" dirty="0"/>
           </a:p>

</xml_diff>